<commit_message>
Harden activity 1 against official guide
</commit_message>
<xml_diff>
--- a/actividad1/slides/Actividad1_AMR_FOD_Kitting.pptx
+++ b/actividad1/slides/Actividad1_AMR_FOD_Kitting.pptx
@@ -4585,7 +4585,7 @@
                 </a:solidFill>
                 <a:latin typeface="Aptos"/>
               </a:rPr>
-              <a:t>Especializacion: robotica movil, integracion industrial y automatizacion intralogistica.</a:t>
+              <a:t>Empresa joven de integracion de robotica movil industrial.</a:t>
             </a:r>
           </a:p>
           <a:p>
@@ -4599,7 +4599,7 @@
                 </a:solidFill>
                 <a:latin typeface="Aptos"/>
               </a:rPr>
-              <a:t>Alcance: diseno teorico, arquitectura, presupuesto, riesgos y plan de implantacion.</a:t>
+              <a:t>Capacidades: CoppeliaSim, AMR, LiDAR/RGB-D/RFID, HMI y datos de planta.</a:t>
             </a:r>
           </a:p>
           <a:p>
@@ -4613,7 +4613,7 @@
                 </a:solidFill>
                 <a:latin typeface="Aptos"/>
               </a:rPr>
-              <a:t>Criterio: no automatizar la fabricacion del HTP, sino los flujos auxiliares que la condicionan.</a:t>
+              <a:t>Experiencia de referencia: pilotos intralogisticos y celdas con bases omnidireccionales.</a:t>
             </a:r>
           </a:p>
           <a:p>
@@ -4627,7 +4627,7 @@
                 </a:solidFill>
                 <a:latin typeface="Aptos"/>
               </a:rPr>
-              <a:t>Entrega orientada a escalado progresivo y supervision humana.</a:t>
+              <a:t>Enfoque comercial: piloto medible, expansion controlada y despliegue con KPIs validados.</a:t>
             </a:r>
           </a:p>
         </p:txBody>

</xml_diff>

<commit_message>
Add course presentations and map activity 1 to topics
</commit_message>
<xml_diff>
--- a/actividad1/slides/Actividad1_AMR_FOD_Kitting.pptx
+++ b/actividad1/slides/Actividad1_AMR_FOD_Kitting.pptx
@@ -855,7 +855,7 @@
                 </a:solidFill>
                 <a:latin typeface="Aptos"/>
               </a:rPr>
-              <a:t>Misiones</a:t>
+              <a:t>Planificacion</a:t>
             </a:r>
           </a:p>
         </p:txBody>
@@ -893,7 +893,7 @@
                 </a:solidFill>
                 <a:latin typeface="Aptos"/>
               </a:rPr>
-              <a:t>colas, prioridades, trazabilidad</a:t>
+              <a:t>A*/Dijkstra, DWA, campos potenciales</a:t>
             </a:r>
           </a:p>
         </p:txBody>
@@ -6509,6 +6509,20 @@
                 <a:latin typeface="Aptos"/>
               </a:rPr>
               <a:t>AMR omnidireccional equivalente a KUKA YouBot/Omnirob en CoppeliaSim.</a:t>
+            </a:r>
+          </a:p>
+          <a:p>
+            <a:pPr marL="285750" indent="-171450">
+              <a:buChar char="•"/>
+            </a:pPr>
+            <a:r>
+              <a:rPr lang="es-ES" sz="1400">
+                <a:solidFill>
+                  <a:srgbClr val="0F172A"/>
+                </a:solidFill>
+                <a:latin typeface="Aptos"/>
+              </a:rPr>
+              <a:t>Ruedas mecanum/suecas para movimiento lateral sin cambiar orientacion.</a:t>
             </a:r>
           </a:p>
           <a:p>

</xml_diff>

<commit_message>
Ground activity 1 budget in commercial references
</commit_message>
<xml_diff>
--- a/actividad1/slides/Actividad1_AMR_FOD_Kitting.pptx
+++ b/actividad1/slides/Actividad1_AMR_FOD_Kitting.pptx
@@ -2260,7 +2260,7 @@
                 </a:solidFill>
                 <a:latin typeface="Aptos"/>
               </a:rPr>
-              <a:t>Coste CAPEX estimado: 206.304 EUR.</a:t>
+              <a:t>Coste CAPEX estimado: 198.688 EUR.</a:t>
             </a:r>
           </a:p>
           <a:p>
@@ -2890,7 +2890,7 @@
                 </a:solidFill>
                 <a:latin typeface="Aptos"/>
               </a:rPr>
-              <a:t>Estimacion academica, no cotizacion real. Importes sin IVA.</a:t>
+              <a:t>Estimacion con referencias comerciales publicas; no cotizacion vinculante. Importes sin IVA.</a:t>
             </a:r>
           </a:p>
         </p:txBody>
@@ -3164,7 +3164,7 @@
                 </a:solidFill>
                 <a:latin typeface="Aptos"/>
               </a:rPr>
-              <a:t>206.304 EUR</a:t>
+              <a:t>198.688 EUR</a:t>
             </a:r>
           </a:p>
         </p:txBody>
@@ -3202,7 +3202,7 @@
                 </a:solidFill>
                 <a:latin typeface="Aptos"/>
               </a:rPr>
-              <a:t>237.704 EUR</a:t>
+              <a:t>242.388 EUR</a:t>
             </a:r>
           </a:p>
         </p:txBody>
@@ -3340,7 +3340,7 @@
                 </a:solidFill>
                 <a:latin typeface="Aptos"/>
               </a:rPr>
-              <a:t>974.848 EUR</a:t>
+              <a:t>904.736 EUR</a:t>
             </a:r>
           </a:p>
         </p:txBody>
@@ -3378,7 +3378,7 @@
                 </a:solidFill>
                 <a:latin typeface="Aptos"/>
               </a:rPr>
-              <a:t>1.121.648 EUR</a:t>
+              <a:t>1.075.636 EUR</a:t>
             </a:r>
           </a:p>
         </p:txBody>
@@ -3516,7 +3516,7 @@
                 </a:solidFill>
                 <a:latin typeface="Aptos"/>
               </a:rPr>
-              <a:t>2.253.888 EUR</a:t>
+              <a:t>2.051.616 EUR</a:t>
             </a:r>
           </a:p>
         </p:txBody>
@@ -3554,7 +3554,7 @@
                 </a:solidFill>
                 <a:latin typeface="Aptos"/>
               </a:rPr>
-              <a:t>2.576.688 EUR</a:t>
+              <a:t>2.436.516 EUR</a:t>
             </a:r>
           </a:p>
         </p:txBody>
@@ -3632,7 +3632,7 @@
                 </a:solidFill>
                 <a:latin typeface="Aptos"/>
               </a:rPr>
-              <a:t>Partidas incluidas: robots, sensores, utiles de transporte, software, ingenieria, instalacion, formacion, mantenimiento, desplazamientos y margen comercial.</a:t>
+              <a:t>Partidas incluidas: AMR-FOD-Kitting, software, ingenieria, CoppeliaSim, instalacion, formacion, mantenimiento, ciberseguridad y margen.</a:t>
             </a:r>
           </a:p>
           <a:p>

</xml_diff>

<commit_message>
Finalize activity 1 report and simulation assets
</commit_message>
<xml_diff>
--- a/actividad1/slides/Actividad1_AMR_FOD_Kitting.pptx
+++ b/actividad1/slides/Actividad1_AMR_FOD_Kitting.pptx
@@ -21,6 +21,14 @@
     <p:sldId id="269" r:id="rId15"/>
     <p:sldId id="270" r:id="rId16"/>
     <p:sldId id="271" r:id="rId17"/>
+    <p:sldId id="272" r:id="rId18"/>
+    <p:sldId id="273" r:id="rId19"/>
+    <p:sldId id="274" r:id="rId20"/>
+    <p:sldId id="275" r:id="rId21"/>
+    <p:sldId id="276" r:id="rId22"/>
+    <p:sldId id="277" r:id="rId23"/>
+    <p:sldId id="278" r:id="rId24"/>
+    <p:sldId id="279" r:id="rId25"/>
   </p:sldIdLst>
   <p:sldSz cx="12191999" cy="6858000" type="wide"/>
   <p:notesSz cx="6858000" cy="9144000"/>
@@ -476,6 +484,153 @@
 </p:sld>
 </file>
 
+<file path=ppt/slides/slide17.xml><?xml version="1.0" encoding="utf-8"?>
+<p:sld xmlns:a="http://schemas.openxmlformats.org/drawingml/2006/main" xmlns:r="http://schemas.openxmlformats.org/officeDocument/2006/relationships" xmlns:p="http://schemas.openxmlformats.org/presentationml/2006/main">
+  <p:cSld>
+    <p:spTree>
+      <p:nvGrpSpPr>
+        <p:cNvPr id="1" name=""/>
+        <p:cNvGrpSpPr/>
+        <p:nvPr/>
+      </p:nvGrpSpPr>
+      <p:grpSpPr>
+        <a:xfrm>
+          <a:off x="0" y="0"/>
+          <a:ext cx="0" cy="0"/>
+          <a:chOff x="0" y="0"/>
+          <a:chExt cx="0" cy="0"/>
+        </a:xfrm>
+      </p:grpSpPr>
+      <p:pic>
+        <p:nvPicPr>
+          <p:cNvPr id="2" name="Slide 17"/>
+          <p:cNvPicPr>
+            <a:picLocks noChangeAspect="1"/>
+          </p:cNvPicPr>
+          <p:nvPr/>
+        </p:nvPicPr>
+        <p:blipFill>
+          <a:blip r:embed="rId2"/>
+          <a:stretch>
+            <a:fillRect/>
+          </a:stretch>
+        </p:blipFill>
+        <p:spPr>
+          <a:xfrm>
+            <a:off x="0" y="0"/>
+            <a:ext cx="12191999" cy="6858000"/>
+          </a:xfrm>
+          <a:prstGeom prst="rect">
+            <a:avLst/>
+          </a:prstGeom>
+        </p:spPr>
+      </p:pic>
+    </p:spTree>
+  </p:cSld>
+  <p:clrMapOvr>
+    <a:masterClrMapping/>
+  </p:clrMapOvr>
+</p:sld>
+</file>
+
+<file path=ppt/slides/slide18.xml><?xml version="1.0" encoding="utf-8"?>
+<p:sld xmlns:a="http://schemas.openxmlformats.org/drawingml/2006/main" xmlns:r="http://schemas.openxmlformats.org/officeDocument/2006/relationships" xmlns:p="http://schemas.openxmlformats.org/presentationml/2006/main">
+  <p:cSld>
+    <p:spTree>
+      <p:nvGrpSpPr>
+        <p:cNvPr id="1" name=""/>
+        <p:cNvGrpSpPr/>
+        <p:nvPr/>
+      </p:nvGrpSpPr>
+      <p:grpSpPr>
+        <a:xfrm>
+          <a:off x="0" y="0"/>
+          <a:ext cx="0" cy="0"/>
+          <a:chOff x="0" y="0"/>
+          <a:chExt cx="0" cy="0"/>
+        </a:xfrm>
+      </p:grpSpPr>
+      <p:pic>
+        <p:nvPicPr>
+          <p:cNvPr id="2" name="Slide 18"/>
+          <p:cNvPicPr>
+            <a:picLocks noChangeAspect="1"/>
+          </p:cNvPicPr>
+          <p:nvPr/>
+        </p:nvPicPr>
+        <p:blipFill>
+          <a:blip r:embed="rId2"/>
+          <a:stretch>
+            <a:fillRect/>
+          </a:stretch>
+        </p:blipFill>
+        <p:spPr>
+          <a:xfrm>
+            <a:off x="0" y="0"/>
+            <a:ext cx="12191999" cy="6858000"/>
+          </a:xfrm>
+          <a:prstGeom prst="rect">
+            <a:avLst/>
+          </a:prstGeom>
+        </p:spPr>
+      </p:pic>
+    </p:spTree>
+  </p:cSld>
+  <p:clrMapOvr>
+    <a:masterClrMapping/>
+  </p:clrMapOvr>
+</p:sld>
+</file>
+
+<file path=ppt/slides/slide19.xml><?xml version="1.0" encoding="utf-8"?>
+<p:sld xmlns:a="http://schemas.openxmlformats.org/drawingml/2006/main" xmlns:r="http://schemas.openxmlformats.org/officeDocument/2006/relationships" xmlns:p="http://schemas.openxmlformats.org/presentationml/2006/main">
+  <p:cSld>
+    <p:spTree>
+      <p:nvGrpSpPr>
+        <p:cNvPr id="1" name=""/>
+        <p:cNvGrpSpPr/>
+        <p:nvPr/>
+      </p:nvGrpSpPr>
+      <p:grpSpPr>
+        <a:xfrm>
+          <a:off x="0" y="0"/>
+          <a:ext cx="0" cy="0"/>
+          <a:chOff x="0" y="0"/>
+          <a:chExt cx="0" cy="0"/>
+        </a:xfrm>
+      </p:grpSpPr>
+      <p:pic>
+        <p:nvPicPr>
+          <p:cNvPr id="2" name="Slide 19"/>
+          <p:cNvPicPr>
+            <a:picLocks noChangeAspect="1"/>
+          </p:cNvPicPr>
+          <p:nvPr/>
+        </p:nvPicPr>
+        <p:blipFill>
+          <a:blip r:embed="rId2"/>
+          <a:stretch>
+            <a:fillRect/>
+          </a:stretch>
+        </p:blipFill>
+        <p:spPr>
+          <a:xfrm>
+            <a:off x="0" y="0"/>
+            <a:ext cx="12191999" cy="6858000"/>
+          </a:xfrm>
+          <a:prstGeom prst="rect">
+            <a:avLst/>
+          </a:prstGeom>
+        </p:spPr>
+      </p:pic>
+    </p:spTree>
+  </p:cSld>
+  <p:clrMapOvr>
+    <a:masterClrMapping/>
+  </p:clrMapOvr>
+</p:sld>
+</file>
+
 <file path=ppt/slides/slide2.xml><?xml version="1.0" encoding="utf-8"?>
 <p:sld xmlns:a="http://schemas.openxmlformats.org/drawingml/2006/main" xmlns:r="http://schemas.openxmlformats.org/officeDocument/2006/relationships" xmlns:p="http://schemas.openxmlformats.org/presentationml/2006/main">
   <p:cSld>
@@ -496,6 +651,251 @@
       <p:pic>
         <p:nvPicPr>
           <p:cNvPr id="2" name="Slide 2"/>
+          <p:cNvPicPr>
+            <a:picLocks noChangeAspect="1"/>
+          </p:cNvPicPr>
+          <p:nvPr/>
+        </p:nvPicPr>
+        <p:blipFill>
+          <a:blip r:embed="rId2"/>
+          <a:stretch>
+            <a:fillRect/>
+          </a:stretch>
+        </p:blipFill>
+        <p:spPr>
+          <a:xfrm>
+            <a:off x="0" y="0"/>
+            <a:ext cx="12191999" cy="6858000"/>
+          </a:xfrm>
+          <a:prstGeom prst="rect">
+            <a:avLst/>
+          </a:prstGeom>
+        </p:spPr>
+      </p:pic>
+    </p:spTree>
+  </p:cSld>
+  <p:clrMapOvr>
+    <a:masterClrMapping/>
+  </p:clrMapOvr>
+</p:sld>
+</file>
+
+<file path=ppt/slides/slide20.xml><?xml version="1.0" encoding="utf-8"?>
+<p:sld xmlns:a="http://schemas.openxmlformats.org/drawingml/2006/main" xmlns:r="http://schemas.openxmlformats.org/officeDocument/2006/relationships" xmlns:p="http://schemas.openxmlformats.org/presentationml/2006/main">
+  <p:cSld>
+    <p:spTree>
+      <p:nvGrpSpPr>
+        <p:cNvPr id="1" name=""/>
+        <p:cNvGrpSpPr/>
+        <p:nvPr/>
+      </p:nvGrpSpPr>
+      <p:grpSpPr>
+        <a:xfrm>
+          <a:off x="0" y="0"/>
+          <a:ext cx="0" cy="0"/>
+          <a:chOff x="0" y="0"/>
+          <a:chExt cx="0" cy="0"/>
+        </a:xfrm>
+      </p:grpSpPr>
+      <p:pic>
+        <p:nvPicPr>
+          <p:cNvPr id="2" name="Slide 20"/>
+          <p:cNvPicPr>
+            <a:picLocks noChangeAspect="1"/>
+          </p:cNvPicPr>
+          <p:nvPr/>
+        </p:nvPicPr>
+        <p:blipFill>
+          <a:blip r:embed="rId2"/>
+          <a:stretch>
+            <a:fillRect/>
+          </a:stretch>
+        </p:blipFill>
+        <p:spPr>
+          <a:xfrm>
+            <a:off x="0" y="0"/>
+            <a:ext cx="12191999" cy="6858000"/>
+          </a:xfrm>
+          <a:prstGeom prst="rect">
+            <a:avLst/>
+          </a:prstGeom>
+        </p:spPr>
+      </p:pic>
+    </p:spTree>
+  </p:cSld>
+  <p:clrMapOvr>
+    <a:masterClrMapping/>
+  </p:clrMapOvr>
+</p:sld>
+</file>
+
+<file path=ppt/slides/slide21.xml><?xml version="1.0" encoding="utf-8"?>
+<p:sld xmlns:a="http://schemas.openxmlformats.org/drawingml/2006/main" xmlns:r="http://schemas.openxmlformats.org/officeDocument/2006/relationships" xmlns:p="http://schemas.openxmlformats.org/presentationml/2006/main">
+  <p:cSld>
+    <p:spTree>
+      <p:nvGrpSpPr>
+        <p:cNvPr id="1" name=""/>
+        <p:cNvGrpSpPr/>
+        <p:nvPr/>
+      </p:nvGrpSpPr>
+      <p:grpSpPr>
+        <a:xfrm>
+          <a:off x="0" y="0"/>
+          <a:ext cx="0" cy="0"/>
+          <a:chOff x="0" y="0"/>
+          <a:chExt cx="0" cy="0"/>
+        </a:xfrm>
+      </p:grpSpPr>
+      <p:pic>
+        <p:nvPicPr>
+          <p:cNvPr id="2" name="Slide 21"/>
+          <p:cNvPicPr>
+            <a:picLocks noChangeAspect="1"/>
+          </p:cNvPicPr>
+          <p:nvPr/>
+        </p:nvPicPr>
+        <p:blipFill>
+          <a:blip r:embed="rId2"/>
+          <a:stretch>
+            <a:fillRect/>
+          </a:stretch>
+        </p:blipFill>
+        <p:spPr>
+          <a:xfrm>
+            <a:off x="0" y="0"/>
+            <a:ext cx="12191999" cy="6858000"/>
+          </a:xfrm>
+          <a:prstGeom prst="rect">
+            <a:avLst/>
+          </a:prstGeom>
+        </p:spPr>
+      </p:pic>
+    </p:spTree>
+  </p:cSld>
+  <p:clrMapOvr>
+    <a:masterClrMapping/>
+  </p:clrMapOvr>
+</p:sld>
+</file>
+
+<file path=ppt/slides/slide22.xml><?xml version="1.0" encoding="utf-8"?>
+<p:sld xmlns:a="http://schemas.openxmlformats.org/drawingml/2006/main" xmlns:r="http://schemas.openxmlformats.org/officeDocument/2006/relationships" xmlns:p="http://schemas.openxmlformats.org/presentationml/2006/main">
+  <p:cSld>
+    <p:spTree>
+      <p:nvGrpSpPr>
+        <p:cNvPr id="1" name=""/>
+        <p:cNvGrpSpPr/>
+        <p:nvPr/>
+      </p:nvGrpSpPr>
+      <p:grpSpPr>
+        <a:xfrm>
+          <a:off x="0" y="0"/>
+          <a:ext cx="0" cy="0"/>
+          <a:chOff x="0" y="0"/>
+          <a:chExt cx="0" cy="0"/>
+        </a:xfrm>
+      </p:grpSpPr>
+      <p:pic>
+        <p:nvPicPr>
+          <p:cNvPr id="2" name="Slide 22"/>
+          <p:cNvPicPr>
+            <a:picLocks noChangeAspect="1"/>
+          </p:cNvPicPr>
+          <p:nvPr/>
+        </p:nvPicPr>
+        <p:blipFill>
+          <a:blip r:embed="rId2"/>
+          <a:stretch>
+            <a:fillRect/>
+          </a:stretch>
+        </p:blipFill>
+        <p:spPr>
+          <a:xfrm>
+            <a:off x="0" y="0"/>
+            <a:ext cx="12191999" cy="6858000"/>
+          </a:xfrm>
+          <a:prstGeom prst="rect">
+            <a:avLst/>
+          </a:prstGeom>
+        </p:spPr>
+      </p:pic>
+    </p:spTree>
+  </p:cSld>
+  <p:clrMapOvr>
+    <a:masterClrMapping/>
+  </p:clrMapOvr>
+</p:sld>
+</file>
+
+<file path=ppt/slides/slide23.xml><?xml version="1.0" encoding="utf-8"?>
+<p:sld xmlns:a="http://schemas.openxmlformats.org/drawingml/2006/main" xmlns:r="http://schemas.openxmlformats.org/officeDocument/2006/relationships" xmlns:p="http://schemas.openxmlformats.org/presentationml/2006/main">
+  <p:cSld>
+    <p:spTree>
+      <p:nvGrpSpPr>
+        <p:cNvPr id="1" name=""/>
+        <p:cNvGrpSpPr/>
+        <p:nvPr/>
+      </p:nvGrpSpPr>
+      <p:grpSpPr>
+        <a:xfrm>
+          <a:off x="0" y="0"/>
+          <a:ext cx="0" cy="0"/>
+          <a:chOff x="0" y="0"/>
+          <a:chExt cx="0" cy="0"/>
+        </a:xfrm>
+      </p:grpSpPr>
+      <p:pic>
+        <p:nvPicPr>
+          <p:cNvPr id="2" name="Slide 23"/>
+          <p:cNvPicPr>
+            <a:picLocks noChangeAspect="1"/>
+          </p:cNvPicPr>
+          <p:nvPr/>
+        </p:nvPicPr>
+        <p:blipFill>
+          <a:blip r:embed="rId2"/>
+          <a:stretch>
+            <a:fillRect/>
+          </a:stretch>
+        </p:blipFill>
+        <p:spPr>
+          <a:xfrm>
+            <a:off x="0" y="0"/>
+            <a:ext cx="12191999" cy="6858000"/>
+          </a:xfrm>
+          <a:prstGeom prst="rect">
+            <a:avLst/>
+          </a:prstGeom>
+        </p:spPr>
+      </p:pic>
+    </p:spTree>
+  </p:cSld>
+  <p:clrMapOvr>
+    <a:masterClrMapping/>
+  </p:clrMapOvr>
+</p:sld>
+</file>
+
+<file path=ppt/slides/slide24.xml><?xml version="1.0" encoding="utf-8"?>
+<p:sld xmlns:a="http://schemas.openxmlformats.org/drawingml/2006/main" xmlns:r="http://schemas.openxmlformats.org/officeDocument/2006/relationships" xmlns:p="http://schemas.openxmlformats.org/presentationml/2006/main">
+  <p:cSld>
+    <p:spTree>
+      <p:nvGrpSpPr>
+        <p:cNvPr id="1" name=""/>
+        <p:cNvGrpSpPr/>
+        <p:nvPr/>
+      </p:nvGrpSpPr>
+      <p:grpSpPr>
+        <a:xfrm>
+          <a:off x="0" y="0"/>
+          <a:ext cx="0" cy="0"/>
+          <a:chOff x="0" y="0"/>
+          <a:chExt cx="0" cy="0"/>
+        </a:xfrm>
+      </p:grpSpPr>
+      <p:pic>
+        <p:nvPicPr>
+          <p:cNvPr id="2" name="Slide 24"/>
           <p:cNvPicPr>
             <a:picLocks noChangeAspect="1"/>
           </p:cNvPicPr>

</xml_diff>